<commit_message>
java7: fix possible multithreading issues
</commit_message>
<xml_diff>
--- a/programming/7/Fixes.pptx
+++ b/programming/7/Fixes.pptx
@@ -10,6 +10,7 @@
     <p:sldId id="259" r:id="rId4"/>
     <p:sldId id="258" r:id="rId5"/>
     <p:sldId id="260" r:id="rId6"/>
+    <p:sldId id="261" r:id="rId7"/>
   </p:sldIdLst>
   <p:sldSz cx="12192000" cy="6858000"/>
   <p:notesSz cx="6858000" cy="9144000"/>
@@ -108,6 +109,11 @@
       </a:defRPr>
     </a:lvl9pPr>
   </p:defaultTextStyle>
+  <p:extLst>
+    <p:ext uri="{EFAFB233-063F-42B5-8137-9DF3F51BA10A}">
+      <p15:sldGuideLst xmlns:p15="http://schemas.microsoft.com/office/powerpoint/2012/main"/>
+    </p:ext>
+  </p:extLst>
 </p:presentation>
 </file>
 
@@ -3983,44 +3989,184 @@
             <p:ph type="title"/>
           </p:nvPr>
         </p:nvSpPr>
-        <p:spPr/>
-        <p:txBody>
-          <a:bodyPr/>
-          <a:lstStyle/>
-          <a:p>
-            <a:endParaRPr lang="ru-RU"/>
-          </a:p>
-        </p:txBody>
-      </p:sp>
-      <p:sp>
-        <p:nvSpPr>
-          <p:cNvPr id="3" name="Объект 2">
-            <a:extLst>
-              <a:ext uri="{FF2B5EF4-FFF2-40B4-BE49-F238E27FC236}">
-                <a16:creationId xmlns:a16="http://schemas.microsoft.com/office/drawing/2014/main" id="{DE7EBFB3-D3A0-EB84-61BE-EEDC5C6FC484}"/>
-              </a:ext>
-            </a:extLst>
-          </p:cNvPr>
-          <p:cNvSpPr>
-            <a:spLocks noGrp="1"/>
-          </p:cNvSpPr>
+        <p:spPr>
+          <a:xfrm>
+            <a:off x="357554" y="18255"/>
+            <a:ext cx="10515600" cy="1325563"/>
+          </a:xfrm>
+        </p:spPr>
+        <p:txBody>
+          <a:bodyPr>
+            <a:normAutofit/>
+          </a:bodyPr>
+          <a:lstStyle/>
+          <a:p>
+            <a:r>
+              <a:rPr lang="en-US" sz="3200" dirty="0"/>
+              <a:t>Server/CommandExecuter.java</a:t>
+            </a:r>
+            <a:endParaRPr lang="ru-RU" sz="3200" dirty="0"/>
+          </a:p>
+        </p:txBody>
+      </p:sp>
+      <p:pic>
+        <p:nvPicPr>
+          <p:cNvPr id="5" name="Объект 4">
+            <a:extLst>
+              <a:ext uri="{FF2B5EF4-FFF2-40B4-BE49-F238E27FC236}">
+                <a16:creationId xmlns:a16="http://schemas.microsoft.com/office/drawing/2014/main" id="{08C9945B-7143-54B2-4D0C-3643D01606B6}"/>
+              </a:ext>
+            </a:extLst>
+          </p:cNvPr>
+          <p:cNvPicPr>
+            <a:picLocks noGrp="1" noChangeAspect="1"/>
+          </p:cNvPicPr>
           <p:nvPr>
             <p:ph idx="1"/>
           </p:nvPr>
-        </p:nvSpPr>
-        <p:spPr/>
-        <p:txBody>
-          <a:bodyPr/>
-          <a:lstStyle/>
-          <a:p>
-            <a:endParaRPr lang="ru-RU" dirty="0"/>
-          </a:p>
-        </p:txBody>
-      </p:sp>
+        </p:nvPicPr>
+        <p:blipFill>
+          <a:blip r:embed="rId2"/>
+          <a:stretch>
+            <a:fillRect/>
+          </a:stretch>
+        </p:blipFill>
+        <p:spPr>
+          <a:xfrm>
+            <a:off x="858279" y="1667363"/>
+            <a:ext cx="4379441" cy="4351338"/>
+          </a:xfrm>
+        </p:spPr>
+      </p:pic>
+      <p:pic>
+        <p:nvPicPr>
+          <p:cNvPr id="7" name="Рисунок 6">
+            <a:extLst>
+              <a:ext uri="{FF2B5EF4-FFF2-40B4-BE49-F238E27FC236}">
+                <a16:creationId xmlns:a16="http://schemas.microsoft.com/office/drawing/2014/main" id="{71A9ED3B-D303-6ACB-4FFB-76FAF2809FBB}"/>
+              </a:ext>
+            </a:extLst>
+          </p:cNvPr>
+          <p:cNvPicPr>
+            <a:picLocks noChangeAspect="1"/>
+          </p:cNvPicPr>
+          <p:nvPr/>
+        </p:nvPicPr>
+        <p:blipFill>
+          <a:blip r:embed="rId3"/>
+          <a:stretch>
+            <a:fillRect/>
+          </a:stretch>
+        </p:blipFill>
+        <p:spPr>
+          <a:xfrm>
+            <a:off x="6251118" y="1343818"/>
+            <a:ext cx="4558171" cy="4812323"/>
+          </a:xfrm>
+          <a:prstGeom prst="rect">
+            <a:avLst/>
+          </a:prstGeom>
+        </p:spPr>
+      </p:pic>
     </p:spTree>
     <p:extLst>
       <p:ext uri="{BB962C8B-B14F-4D97-AF65-F5344CB8AC3E}">
         <p14:creationId xmlns:p14="http://schemas.microsoft.com/office/powerpoint/2010/main" val="116770513"/>
+      </p:ext>
+    </p:extLst>
+  </p:cSld>
+  <p:clrMapOvr>
+    <a:masterClrMapping/>
+  </p:clrMapOvr>
+</p:sld>
+</file>
+
+<file path=ppt/slides/slide6.xml><?xml version="1.0" encoding="utf-8"?>
+<p:sld xmlns:a="http://schemas.openxmlformats.org/drawingml/2006/main" xmlns:r="http://schemas.openxmlformats.org/officeDocument/2006/relationships" xmlns:p="http://schemas.openxmlformats.org/presentationml/2006/main">
+  <p:cSld>
+    <p:spTree>
+      <p:nvGrpSpPr>
+        <p:cNvPr id="1" name=""/>
+        <p:cNvGrpSpPr/>
+        <p:nvPr/>
+      </p:nvGrpSpPr>
+      <p:grpSpPr>
+        <a:xfrm>
+          <a:off x="0" y="0"/>
+          <a:ext cx="0" cy="0"/>
+          <a:chOff x="0" y="0"/>
+          <a:chExt cx="0" cy="0"/>
+        </a:xfrm>
+      </p:grpSpPr>
+      <p:sp>
+        <p:nvSpPr>
+          <p:cNvPr id="2" name="Заголовок 1">
+            <a:extLst>
+              <a:ext uri="{FF2B5EF4-FFF2-40B4-BE49-F238E27FC236}">
+                <a16:creationId xmlns:a16="http://schemas.microsoft.com/office/drawing/2014/main" id="{3C962290-352F-AC54-DD06-DACC4E1A472D}"/>
+              </a:ext>
+            </a:extLst>
+          </p:cNvPr>
+          <p:cNvSpPr>
+            <a:spLocks noGrp="1"/>
+          </p:cNvSpPr>
+          <p:nvPr>
+            <p:ph type="title"/>
+          </p:nvPr>
+        </p:nvSpPr>
+        <p:spPr>
+          <a:xfrm>
+            <a:off x="357554" y="18255"/>
+            <a:ext cx="10515600" cy="1325563"/>
+          </a:xfrm>
+        </p:spPr>
+        <p:txBody>
+          <a:bodyPr>
+            <a:normAutofit/>
+          </a:bodyPr>
+          <a:lstStyle/>
+          <a:p>
+            <a:r>
+              <a:rPr lang="en-US" sz="3200" dirty="0"/>
+              <a:t>Server/CommandExecuter.java</a:t>
+            </a:r>
+            <a:endParaRPr lang="ru-RU" sz="3200" dirty="0"/>
+          </a:p>
+        </p:txBody>
+      </p:sp>
+      <p:pic>
+        <p:nvPicPr>
+          <p:cNvPr id="8" name="Объект 7">
+            <a:extLst>
+              <a:ext uri="{FF2B5EF4-FFF2-40B4-BE49-F238E27FC236}">
+                <a16:creationId xmlns:a16="http://schemas.microsoft.com/office/drawing/2014/main" id="{C8F25378-FC59-0496-0EE3-0330E9F445B1}"/>
+              </a:ext>
+            </a:extLst>
+          </p:cNvPr>
+          <p:cNvPicPr>
+            <a:picLocks noGrp="1" noChangeAspect="1"/>
+          </p:cNvPicPr>
+          <p:nvPr>
+            <p:ph idx="1"/>
+          </p:nvPr>
+        </p:nvPicPr>
+        <p:blipFill>
+          <a:blip r:embed="rId2"/>
+          <a:stretch>
+            <a:fillRect/>
+          </a:stretch>
+        </p:blipFill>
+        <p:spPr>
+          <a:xfrm>
+            <a:off x="1579294" y="1550133"/>
+            <a:ext cx="7497690" cy="4351338"/>
+          </a:xfrm>
+        </p:spPr>
+      </p:pic>
+    </p:spTree>
+    <p:extLst>
+      <p:ext uri="{BB962C8B-B14F-4D97-AF65-F5344CB8AC3E}">
+        <p14:creationId xmlns:p14="http://schemas.microsoft.com/office/powerpoint/2010/main" val="1482965057"/>
       </p:ext>
     </p:extLst>
   </p:cSld>

</xml_diff>